<commit_message>
Fase 3: informe final consolidado, MU-05, reportes BI y paquete de entrega
- Informe final de 55 paginas con las 16 secciones de los cuatro integrantes,
  indice con numeros de pagina, 39 figuras y 9 tablas, sin marcadores pendientes
- Secciones 4.2, 11, 12, 14, 15 y 16 redactadas con los numeros de cierre leidos
  de la instancia: 63 pedidos por Q 21,366.00, ticket Q 339.14, recompra 29.8 %,
  entregas en menos de 24 h 90.2 %, cero productos en quiebre
- MU-05 armado con la evidencia de los casos WEB; MU-06 limpiado y renombrado;
  los tres manuales unidos en un solo PDF
- Capturas de los seis reportes de inteligencia de negocios en 6_Reportes_BI
- Presentacion completada: capturas en lugar de los recuadros y los resultados
  en las tablas de indicadores y de casos
- LEEME_PRIMERO con la guia del paquete y la direccion del prototipo
</commit_message>
<xml_diff>
--- a/Entrega_Fase3_Grupo14/5_Presentacion/Presentacion_Fase3_Grupo14.pptx
+++ b/Entrega_Fase3_Grupo14/5_Presentacion/Presentacion_Fase3_Grupo14.pptx
@@ -4815,171 +4815,78 @@
           </a:p>
         </p:txBody>
       </p:sp>
-      <p:sp>
-        <p:nvSpPr>
-          <p:cNvPr id="9" name="Rectangle 8"/>
-          <p:cNvSpPr/>
-          <p:nvPr/>
-        </p:nvSpPr>
-        <p:spPr>
-          <a:xfrm>
-            <a:off x="548640" y="1828800"/>
-            <a:ext cx="3657600" cy="4206240"/>
+      <p:pic>
+        <p:nvPicPr>
+          <p:cNvPr id="12" name="Picture 11" descr="b02_existencias_barras.png"/>
+          <p:cNvPicPr>
+            <a:picLocks noChangeAspect="1"/>
+          </p:cNvPicPr>
+          <p:nvPr/>
+        </p:nvPicPr>
+        <p:blipFill>
+          <a:blip r:embed="rId2"/>
+          <a:stretch>
+            <a:fillRect/>
+          </a:stretch>
+        </p:blipFill>
+        <p:spPr>
+          <a:xfrm>
+            <a:off x="548640" y="2903220"/>
+            <a:ext cx="3657600" cy="2057400"/>
           </a:xfrm>
           <a:prstGeom prst="rect">
             <a:avLst/>
           </a:prstGeom>
-          <a:solidFill>
-            <a:srgbClr val="F3F6FA"/>
-          </a:solidFill>
-          <a:ln>
-            <a:solidFill>
-              <a:srgbClr val="8A9BB5"/>
-            </a:solidFill>
-            <a:prstDash val="dash"/>
-          </a:ln>
-        </p:spPr>
-        <p:style>
-          <a:lnRef idx="1">
-            <a:schemeClr val="accent1"/>
-          </a:lnRef>
-          <a:fillRef idx="3">
-            <a:schemeClr val="accent1"/>
-          </a:fillRef>
-          <a:effectRef idx="2">
-            <a:schemeClr val="accent1"/>
-          </a:effectRef>
-          <a:fontRef idx="minor">
-            <a:schemeClr val="lt1"/>
-          </a:fontRef>
-        </p:style>
-        <p:txBody>
-          <a:bodyPr rtlCol="0" anchor="ctr" wrap="square"/>
-          <a:lstStyle/>
-          <a:p>
-            <a:pPr algn="ctr"/>
-            <a:r>
-              <a:rPr sz="1400" i="1">
-                <a:solidFill>
-                  <a:srgbClr val="8A9BB5"/>
-                </a:solidFill>
-                <a:latin typeface="Segoe UI"/>
-              </a:rPr>
-              <a:t>[Captura: barras: existencias por producto]</a:t>
-            </a:r>
-          </a:p>
-        </p:txBody>
-      </p:sp>
-      <p:sp>
-        <p:nvSpPr>
-          <p:cNvPr id="10" name="Rectangle 9"/>
-          <p:cNvSpPr/>
-          <p:nvPr/>
-        </p:nvSpPr>
-        <p:spPr>
-          <a:xfrm>
-            <a:off x="4343400" y="1828800"/>
-            <a:ext cx="3657600" cy="4206240"/>
+        </p:spPr>
+      </p:pic>
+      <p:pic>
+        <p:nvPicPr>
+          <p:cNvPr id="13" name="Picture 12" descr="b03_inventario_pastel.png"/>
+          <p:cNvPicPr>
+            <a:picLocks noChangeAspect="1"/>
+          </p:cNvPicPr>
+          <p:nvPr/>
+        </p:nvPicPr>
+        <p:blipFill>
+          <a:blip r:embed="rId3"/>
+          <a:stretch>
+            <a:fillRect/>
+          </a:stretch>
+        </p:blipFill>
+        <p:spPr>
+          <a:xfrm>
+            <a:off x="4343400" y="2903220"/>
+            <a:ext cx="3657600" cy="2057400"/>
           </a:xfrm>
           <a:prstGeom prst="rect">
             <a:avLst/>
           </a:prstGeom>
-          <a:solidFill>
-            <a:srgbClr val="F3F6FA"/>
-          </a:solidFill>
-          <a:ln>
-            <a:solidFill>
-              <a:srgbClr val="8A9BB5"/>
-            </a:solidFill>
-            <a:prstDash val="dash"/>
-          </a:ln>
-        </p:spPr>
-        <p:style>
-          <a:lnRef idx="1">
-            <a:schemeClr val="accent1"/>
-          </a:lnRef>
-          <a:fillRef idx="3">
-            <a:schemeClr val="accent1"/>
-          </a:fillRef>
-          <a:effectRef idx="2">
-            <a:schemeClr val="accent1"/>
-          </a:effectRef>
-          <a:fontRef idx="minor">
-            <a:schemeClr val="lt1"/>
-          </a:fontRef>
-        </p:style>
-        <p:txBody>
-          <a:bodyPr rtlCol="0" anchor="ctr" wrap="square"/>
-          <a:lstStyle/>
-          <a:p>
-            <a:pPr algn="ctr"/>
-            <a:r>
-              <a:rPr sz="1400" i="1">
-                <a:solidFill>
-                  <a:srgbClr val="8A9BB5"/>
-                </a:solidFill>
-                <a:latin typeface="Segoe UI"/>
-              </a:rPr>
-              <a:t>[Captura: pastel: inventario por categoría]</a:t>
-            </a:r>
-          </a:p>
-        </p:txBody>
-      </p:sp>
-      <p:sp>
-        <p:nvSpPr>
-          <p:cNvPr id="11" name="Rectangle 10"/>
-          <p:cNvSpPr/>
-          <p:nvPr/>
-        </p:nvSpPr>
-        <p:spPr>
-          <a:xfrm>
-            <a:off x="8138160" y="1828800"/>
-            <a:ext cx="3566160" cy="4206240"/>
+        </p:spPr>
+      </p:pic>
+      <p:pic>
+        <p:nvPicPr>
+          <p:cNvPr id="14" name="Picture 13" descr="b04_stock_bajo.png"/>
+          <p:cNvPicPr>
+            <a:picLocks noChangeAspect="1"/>
+          </p:cNvPicPr>
+          <p:nvPr/>
+        </p:nvPicPr>
+        <p:blipFill>
+          <a:blip r:embed="rId4"/>
+          <a:stretch>
+            <a:fillRect/>
+          </a:stretch>
+        </p:blipFill>
+        <p:spPr>
+          <a:xfrm>
+            <a:off x="8138160" y="2928937"/>
+            <a:ext cx="3566160" cy="2005965"/>
           </a:xfrm>
           <a:prstGeom prst="rect">
             <a:avLst/>
           </a:prstGeom>
-          <a:solidFill>
-            <a:srgbClr val="F3F6FA"/>
-          </a:solidFill>
-          <a:ln>
-            <a:solidFill>
-              <a:srgbClr val="8A9BB5"/>
-            </a:solidFill>
-            <a:prstDash val="dash"/>
-          </a:ln>
-        </p:spPr>
-        <p:style>
-          <a:lnRef idx="1">
-            <a:schemeClr val="accent1"/>
-          </a:lnRef>
-          <a:fillRef idx="3">
-            <a:schemeClr val="accent1"/>
-          </a:fillRef>
-          <a:effectRef idx="2">
-            <a:schemeClr val="accent1"/>
-          </a:effectRef>
-          <a:fontRef idx="minor">
-            <a:schemeClr val="lt1"/>
-          </a:fontRef>
-        </p:style>
-        <p:txBody>
-          <a:bodyPr rtlCol="0" anchor="ctr" wrap="square"/>
-          <a:lstStyle/>
-          <a:p>
-            <a:pPr algn="ctr"/>
-            <a:r>
-              <a:rPr sz="1400" i="1">
-                <a:solidFill>
-                  <a:srgbClr val="8A9BB5"/>
-                </a:solidFill>
-                <a:latin typeface="Segoe UI"/>
-              </a:rPr>
-              <a:t>[Captura: tabla: productos bajo el mínimo]</a:t>
-            </a:r>
-          </a:p>
-        </p:txBody>
-      </p:sp>
+        </p:spPr>
+      </p:pic>
     </p:spTree>
   </p:cSld>
   <p:clrMapOvr>
@@ -5292,116 +5199,54 @@
           </a:p>
         </p:txBody>
       </p:sp>
-      <p:sp>
-        <p:nvSpPr>
-          <p:cNvPr id="9" name="Rectangle 8"/>
-          <p:cNvSpPr/>
-          <p:nvPr/>
-        </p:nvSpPr>
-        <p:spPr>
-          <a:xfrm>
-            <a:off x="548640" y="1828800"/>
-            <a:ext cx="6766560" cy="4206240"/>
+      <p:pic>
+        <p:nvPicPr>
+          <p:cNvPr id="11" name="Picture 10" descr="f21_evolucion_ventas.png"/>
+          <p:cNvPicPr>
+            <a:picLocks noChangeAspect="1"/>
+          </p:cNvPicPr>
+          <p:nvPr/>
+        </p:nvPicPr>
+        <p:blipFill>
+          <a:blip r:embed="rId3"/>
+          <a:stretch>
+            <a:fillRect/>
+          </a:stretch>
+        </p:blipFill>
+        <p:spPr>
+          <a:xfrm>
+            <a:off x="548640" y="2860972"/>
+            <a:ext cx="6766560" cy="2141896"/>
           </a:xfrm>
           <a:prstGeom prst="rect">
             <a:avLst/>
           </a:prstGeom>
-          <a:solidFill>
-            <a:srgbClr val="F3F6FA"/>
-          </a:solidFill>
-          <a:ln>
-            <a:solidFill>
-              <a:srgbClr val="8A9BB5"/>
-            </a:solidFill>
-            <a:prstDash val="dash"/>
-          </a:ln>
-        </p:spPr>
-        <p:style>
-          <a:lnRef idx="1">
-            <a:schemeClr val="accent1"/>
-          </a:lnRef>
-          <a:fillRef idx="3">
-            <a:schemeClr val="accent1"/>
-          </a:fillRef>
-          <a:effectRef idx="2">
-            <a:schemeClr val="accent1"/>
-          </a:effectRef>
-          <a:fontRef idx="minor">
-            <a:schemeClr val="lt1"/>
-          </a:fontRef>
-        </p:style>
-        <p:txBody>
-          <a:bodyPr rtlCol="0" anchor="ctr" wrap="square"/>
-          <a:lstStyle/>
-          <a:p>
-            <a:pPr algn="ctr"/>
-            <a:r>
-              <a:rPr sz="1400" i="1">
-                <a:solidFill>
-                  <a:srgbClr val="8A9BB5"/>
-                </a:solidFill>
-                <a:latin typeface="Segoe UI"/>
-              </a:rPr>
-              <a:t>[Captura: líneas: ventas por día (cambiar a semana y mes en vivo)]</a:t>
-            </a:r>
-          </a:p>
-        </p:txBody>
-      </p:sp>
-      <p:sp>
-        <p:nvSpPr>
-          <p:cNvPr id="10" name="Rectangle 9"/>
-          <p:cNvSpPr/>
-          <p:nvPr/>
-        </p:nvSpPr>
-        <p:spPr>
-          <a:xfrm>
-            <a:off x="7680960" y="1828800"/>
-            <a:ext cx="4023360" cy="4206240"/>
+        </p:spPr>
+      </p:pic>
+      <p:pic>
+        <p:nvPicPr>
+          <p:cNvPr id="12" name="Picture 11" descr="b05_top5.png"/>
+          <p:cNvPicPr>
+            <a:picLocks noChangeAspect="1"/>
+          </p:cNvPicPr>
+          <p:nvPr/>
+        </p:nvPicPr>
+        <p:blipFill>
+          <a:blip r:embed="rId4"/>
+          <a:stretch>
+            <a:fillRect/>
+          </a:stretch>
+        </p:blipFill>
+        <p:spPr>
+          <a:xfrm>
+            <a:off x="7680960" y="2800350"/>
+            <a:ext cx="4023360" cy="2263140"/>
           </a:xfrm>
           <a:prstGeom prst="rect">
             <a:avLst/>
           </a:prstGeom>
-          <a:solidFill>
-            <a:srgbClr val="F3F6FA"/>
-          </a:solidFill>
-          <a:ln>
-            <a:solidFill>
-              <a:srgbClr val="8A9BB5"/>
-            </a:solidFill>
-            <a:prstDash val="dash"/>
-          </a:ln>
-        </p:spPr>
-        <p:style>
-          <a:lnRef idx="1">
-            <a:schemeClr val="accent1"/>
-          </a:lnRef>
-          <a:fillRef idx="3">
-            <a:schemeClr val="accent1"/>
-          </a:fillRef>
-          <a:effectRef idx="2">
-            <a:schemeClr val="accent1"/>
-          </a:effectRef>
-          <a:fontRef idx="minor">
-            <a:schemeClr val="lt1"/>
-          </a:fontRef>
-        </p:style>
-        <p:txBody>
-          <a:bodyPr rtlCol="0" anchor="ctr" wrap="square"/>
-          <a:lstStyle/>
-          <a:p>
-            <a:pPr algn="ctr"/>
-            <a:r>
-              <a:rPr sz="1400" i="1">
-                <a:solidFill>
-                  <a:srgbClr val="8A9BB5"/>
-                </a:solidFill>
-                <a:latin typeface="Segoe UI"/>
-              </a:rPr>
-              <a:t>[Captura: top 5 de productos por cantidad]</a:t>
-            </a:r>
-          </a:p>
-        </p:txBody>
-      </p:sp>
+        </p:spPr>
+      </p:pic>
     </p:spTree>
   </p:cSld>
   <p:clrMapOvr>
@@ -5827,13 +5672,12 @@
                     <a:lstStyle/>
                     <a:p>
                       <a:r>
-                        <a:rPr sz="1400" b="0">
+                        <a:rPr sz="1200" b="1">
                           <a:solidFill>
-                            <a:srgbClr val="595959"/>
+                            <a:srgbClr val="4A4A4A"/>
                           </a:solidFill>
-                          <a:latin typeface="Segoe UI"/>
                         </a:rPr>
-                        <a:t>—</a:t>
+                        <a:t>Q 339.14</a:t>
                       </a:r>
                     </a:p>
                   </a:txBody>
@@ -5849,13 +5693,12 @@
                     <a:lstStyle/>
                     <a:p>
                       <a:r>
-                        <a:rPr sz="1400" b="0">
+                        <a:rPr sz="1100" b="0">
                           <a:solidFill>
-                            <a:srgbClr val="595959"/>
+                            <a:srgbClr val="4A4A4A"/>
                           </a:solidFill>
-                          <a:latin typeface="Segoe UI"/>
                         </a:rPr>
-                        <a:t>—</a:t>
+                        <a:t>Sí</a:t>
                       </a:r>
                     </a:p>
                   </a:txBody>
@@ -5917,13 +5760,12 @@
                     <a:lstStyle/>
                     <a:p>
                       <a:r>
-                        <a:rPr sz="1400" b="0">
+                        <a:rPr sz="1200" b="1">
                           <a:solidFill>
-                            <a:srgbClr val="595959"/>
+                            <a:srgbClr val="4A4A4A"/>
                           </a:solidFill>
-                          <a:latin typeface="Segoe UI"/>
                         </a:rPr>
-                        <a:t>—</a:t>
+                        <a:t>29.8 %</a:t>
                       </a:r>
                     </a:p>
                   </a:txBody>
@@ -5939,13 +5781,12 @@
                     <a:lstStyle/>
                     <a:p>
                       <a:r>
-                        <a:rPr sz="1400" b="0">
+                        <a:rPr sz="1100" b="0">
                           <a:solidFill>
-                            <a:srgbClr val="595959"/>
+                            <a:srgbClr val="4A4A4A"/>
                           </a:solidFill>
-                          <a:latin typeface="Segoe UI"/>
                         </a:rPr>
-                        <a:t>—</a:t>
+                        <a:t>Sí</a:t>
                       </a:r>
                     </a:p>
                   </a:txBody>
@@ -6007,13 +5848,12 @@
                     <a:lstStyle/>
                     <a:p>
                       <a:r>
-                        <a:rPr sz="1400" b="0">
+                        <a:rPr sz="1200" b="1">
                           <a:solidFill>
-                            <a:srgbClr val="595959"/>
+                            <a:srgbClr val="4A4A4A"/>
                           </a:solidFill>
-                          <a:latin typeface="Segoe UI"/>
                         </a:rPr>
-                        <a:t>—</a:t>
+                        <a:t>90.2 %</a:t>
                       </a:r>
                     </a:p>
                   </a:txBody>
@@ -6029,13 +5869,12 @@
                     <a:lstStyle/>
                     <a:p>
                       <a:r>
-                        <a:rPr sz="1400" b="0">
+                        <a:rPr sz="1100" b="0">
                           <a:solidFill>
-                            <a:srgbClr val="595959"/>
+                            <a:srgbClr val="4A4A4A"/>
                           </a:solidFill>
-                          <a:latin typeface="Segoe UI"/>
                         </a:rPr>
-                        <a:t>—</a:t>
+                        <a:t>Sí</a:t>
                       </a:r>
                     </a:p>
                   </a:txBody>
@@ -6097,13 +5936,12 @@
                     <a:lstStyle/>
                     <a:p>
                       <a:r>
-                        <a:rPr sz="1400" b="0">
+                        <a:rPr sz="1200" b="1">
                           <a:solidFill>
-                            <a:srgbClr val="595959"/>
+                            <a:srgbClr val="4A4A4A"/>
                           </a:solidFill>
-                          <a:latin typeface="Segoe UI"/>
                         </a:rPr>
-                        <a:t>—</a:t>
+                        <a:t>0 de 38</a:t>
                       </a:r>
                     </a:p>
                   </a:txBody>
@@ -6119,13 +5957,12 @@
                     <a:lstStyle/>
                     <a:p>
                       <a:r>
-                        <a:rPr sz="1400" b="0">
+                        <a:rPr sz="1100" b="0">
                           <a:solidFill>
-                            <a:srgbClr val="595959"/>
+                            <a:srgbClr val="4A4A4A"/>
                           </a:solidFill>
-                          <a:latin typeface="Segoe UI"/>
                         </a:rPr>
-                        <a:t>—</a:t>
+                        <a:t>Sí</a:t>
                       </a:r>
                     </a:p>
                   </a:txBody>
@@ -6187,13 +6024,12 @@
                     <a:lstStyle/>
                     <a:p>
                       <a:r>
-                        <a:rPr sz="1400" b="0">
+                        <a:rPr sz="1200" b="0">
                           <a:solidFill>
-                            <a:srgbClr val="595959"/>
+                            <a:srgbClr val="4A4A4A"/>
                           </a:solidFill>
-                          <a:latin typeface="Segoe UI"/>
                         </a:rPr>
-                        <a:t>—</a:t>
+                        <a:t>No medido</a:t>
                       </a:r>
                     </a:p>
                   </a:txBody>
@@ -6209,13 +6045,12 @@
                     <a:lstStyle/>
                     <a:p>
                       <a:r>
-                        <a:rPr sz="1400" b="0">
+                        <a:rPr sz="1100" b="0">
                           <a:solidFill>
-                            <a:srgbClr val="595959"/>
+                            <a:srgbClr val="4A4A4A"/>
                           </a:solidFill>
-                          <a:latin typeface="Segoe UI"/>
                         </a:rPr>
-                        <a:t>Muestra del prototipo</a:t>
+                        <a:t>Falta analítica de visitantes</a:t>
                       </a:r>
                     </a:p>
                   </a:txBody>
@@ -6277,11 +6112,10 @@
                     <a:lstStyle/>
                     <a:p>
                       <a:r>
-                        <a:rPr sz="1400" b="0">
+                        <a:rPr sz="1200" b="0">
                           <a:solidFill>
-                            <a:srgbClr val="595959"/>
+                            <a:srgbClr val="4A4A4A"/>
                           </a:solidFill>
-                          <a:latin typeface="Segoe UI"/>
                         </a:rPr>
                         <a:t>No medido</a:t>
                       </a:r>
@@ -6299,11 +6133,10 @@
                     <a:lstStyle/>
                     <a:p>
                       <a:r>
-                        <a:rPr sz="1400" b="0">
+                        <a:rPr sz="1100" b="0">
                           <a:solidFill>
-                            <a:srgbClr val="595959"/>
+                            <a:srgbClr val="4A4A4A"/>
                           </a:solidFill>
-                          <a:latin typeface="Segoe UI"/>
                         </a:rPr>
                         <a:t>Va en escalabilidad</a:t>
                       </a:r>
@@ -7338,49 +7171,46 @@
           <a:p>
             <a:pPr algn="l">
               <a:spcAft>
-                <a:spcPts val="600"/>
+                <a:spcPts val="1400"/>
               </a:spcAft>
             </a:pPr>
             <a:r>
-              <a:rPr sz="2000" b="0">
-                <a:solidFill>
-                  <a:srgbClr val="595959"/>
-                </a:solidFill>
-                <a:latin typeface="Segoe UI"/>
+              <a:rPr sz="1500">
+                <a:solidFill>
+                  <a:srgbClr val="4A4A4A"/>
+                </a:solidFill>
               </a:rPr>
-              <a:t>1.  —</a:t>
-            </a:r>
-          </a:p>
-          <a:p>
-            <a:pPr algn="l">
+              <a:t>1.  La integración quedó demostrada sobre un mismo registro: el pedido S00055 nació de un formulario del sitio, pasó por el CRM, se aceptó en el portal y generó la entrega RMT/OUT/00053 y la factura INV/2026/00054, las tres con el mismo origen. Nadie copió un dato de un sistema a otro.</a:t>
+            </a:r>
+          </a:p>
+          <a:p>
+            <a:pPr>
               <a:spcAft>
-                <a:spcPts val="600"/>
+                <a:spcPts val="1400"/>
               </a:spcAft>
             </a:pPr>
             <a:r>
-              <a:rPr sz="2000" b="0">
-                <a:solidFill>
-                  <a:srgbClr val="595959"/>
-                </a:solidFill>
-                <a:latin typeface="Segoe UI"/>
+              <a:rPr sz="1500">
+                <a:solidFill>
+                  <a:srgbClr val="4A4A4A"/>
+                </a:solidFill>
               </a:rPr>
-              <a:t>2.  —</a:t>
-            </a:r>
-          </a:p>
-          <a:p>
-            <a:pPr algn="l">
+              <a:t>2.  Las cuatro metas operativas de la Fase 1 se cumplen con datos del ERP: ticket de Q 339.14 contra Q 285, recompra del 29.8 % contra 20 %, entregas en menos de 24 horas del 90.2 % contra 90 %, y cero productos en quiebre de 38.</a:t>
+            </a:r>
+          </a:p>
+          <a:p>
+            <a:pPr>
               <a:spcAft>
-                <a:spcPts val="600"/>
+                <a:spcPts val="1400"/>
               </a:spcAft>
             </a:pPr>
             <a:r>
-              <a:rPr sz="2000" b="0">
-                <a:solidFill>
-                  <a:srgbClr val="595959"/>
-                </a:solidFill>
-                <a:latin typeface="Segoe UI"/>
+              <a:rPr sz="1500">
+                <a:solidFill>
+                  <a:srgbClr val="4A4A4A"/>
+                </a:solidFill>
               </a:rPr>
-              <a:t>3.  —</a:t>
+              <a:t>3.  Las metas que dependen de clientes reales, la conversión del sitio y la satisfacción postventa, quedan sin medir y se declaran como tales: hacen falta analítica de visitantes y una encuesta, que es lo que propone la escalabilidad.</a:t>
             </a:r>
           </a:p>
         </p:txBody>
@@ -9310,61 +9140,6 @@
       </p:sp>
       <p:sp>
         <p:nvSpPr>
-          <p:cNvPr id="9" name="Rectangle 8"/>
-          <p:cNvSpPr/>
-          <p:nvPr/>
-        </p:nvSpPr>
-        <p:spPr>
-          <a:xfrm>
-            <a:off x="548640" y="1828800"/>
-            <a:ext cx="6766560" cy="4206240"/>
-          </a:xfrm>
-          <a:prstGeom prst="rect">
-            <a:avLst/>
-          </a:prstGeom>
-          <a:solidFill>
-            <a:srgbClr val="F3F6FA"/>
-          </a:solidFill>
-          <a:ln>
-            <a:solidFill>
-              <a:srgbClr val="8A9BB5"/>
-            </a:solidFill>
-            <a:prstDash val="dash"/>
-          </a:ln>
-        </p:spPr>
-        <p:style>
-          <a:lnRef idx="1">
-            <a:schemeClr val="accent1"/>
-          </a:lnRef>
-          <a:fillRef idx="3">
-            <a:schemeClr val="accent1"/>
-          </a:fillRef>
-          <a:effectRef idx="2">
-            <a:schemeClr val="accent1"/>
-          </a:effectRef>
-          <a:fontRef idx="minor">
-            <a:schemeClr val="lt1"/>
-          </a:fontRef>
-        </p:style>
-        <p:txBody>
-          <a:bodyPr rtlCol="0" anchor="ctr" wrap="square"/>
-          <a:lstStyle/>
-          <a:p>
-            <a:pPr algn="ctr"/>
-            <a:r>
-              <a:rPr sz="1400" i="1">
-                <a:solidFill>
-                  <a:srgbClr val="8A9BB5"/>
-                </a:solidFill>
-                <a:latin typeface="Segoe UI"/>
-              </a:rPr>
-              <a:t>[Captura: tienda con las 6 categorías y los productos con imagen y precio]</a:t>
-            </a:r>
-          </a:p>
-        </p:txBody>
-      </p:sp>
-      <p:sp>
-        <p:nvSpPr>
           <p:cNvPr id="10" name="TextBox 9"/>
           <p:cNvSpPr txBox="1"/>
           <p:nvPr/>
@@ -9466,6 +9241,30 @@
           </a:p>
         </p:txBody>
       </p:sp>
+      <p:pic>
+        <p:nvPicPr>
+          <p:cNvPr id="11" name="Picture 10" descr="f07_tienda.png"/>
+          <p:cNvPicPr>
+            <a:picLocks noChangeAspect="1"/>
+          </p:cNvPicPr>
+          <p:nvPr/>
+        </p:nvPicPr>
+        <p:blipFill>
+          <a:blip r:embed="rId3"/>
+          <a:stretch>
+            <a:fillRect/>
+          </a:stretch>
+        </p:blipFill>
+        <p:spPr>
+          <a:xfrm>
+            <a:off x="548640" y="2016592"/>
+            <a:ext cx="6766560" cy="3830655"/>
+          </a:xfrm>
+          <a:prstGeom prst="rect">
+            <a:avLst/>
+          </a:prstGeom>
+        </p:spPr>
+      </p:pic>
     </p:spTree>
   </p:cSld>
   <p:clrMapOvr>
@@ -10415,61 +10214,30 @@
           </a:p>
         </p:txBody>
       </p:sp>
-      <p:sp>
-        <p:nvSpPr>
-          <p:cNvPr id="23" name="Rectangle 22"/>
-          <p:cNvSpPr/>
-          <p:nvPr/>
-        </p:nvSpPr>
-        <p:spPr>
-          <a:xfrm>
-            <a:off x="548640" y="3931920"/>
-            <a:ext cx="10972800" cy="2194560"/>
+      <p:pic>
+        <p:nvPicPr>
+          <p:cNvPr id="23" name="Picture 22" descr="f16_pedido_s00013.png"/>
+          <p:cNvPicPr>
+            <a:picLocks noChangeAspect="1"/>
+          </p:cNvPicPr>
+          <p:nvPr/>
+        </p:nvPicPr>
+        <p:blipFill>
+          <a:blip r:embed="rId3"/>
+          <a:stretch>
+            <a:fillRect/>
+          </a:stretch>
+        </p:blipFill>
+        <p:spPr>
+          <a:xfrm>
+            <a:off x="4011865" y="3931920"/>
+            <a:ext cx="4046350" cy="2194560"/>
           </a:xfrm>
           <a:prstGeom prst="rect">
             <a:avLst/>
           </a:prstGeom>
-          <a:solidFill>
-            <a:srgbClr val="F3F6FA"/>
-          </a:solidFill>
-          <a:ln>
-            <a:solidFill>
-              <a:srgbClr val="8A9BB5"/>
-            </a:solidFill>
-            <a:prstDash val="dash"/>
-          </a:ln>
-        </p:spPr>
-        <p:style>
-          <a:lnRef idx="1">
-            <a:schemeClr val="accent1"/>
-          </a:lnRef>
-          <a:fillRef idx="3">
-            <a:schemeClr val="accent1"/>
-          </a:fillRef>
-          <a:effectRef idx="2">
-            <a:schemeClr val="accent1"/>
-          </a:effectRef>
-          <a:fontRef idx="minor">
-            <a:schemeClr val="lt1"/>
-          </a:fontRef>
-        </p:style>
-        <p:txBody>
-          <a:bodyPr rtlCol="0" anchor="ctr" wrap="square"/>
-          <a:lstStyle/>
-          <a:p>
-            <a:pPr algn="ctr"/>
-            <a:r>
-              <a:rPr sz="1400" i="1">
-                <a:solidFill>
-                  <a:srgbClr val="8A9BB5"/>
-                </a:solidFill>
-                <a:latin typeface="Segoe UI"/>
-              </a:rPr>
-              <a:t>[Captura: el mismo pedido en Ventas, en la factura y en la entrega]</a:t>
-            </a:r>
-          </a:p>
-        </p:txBody>
-      </p:sp>
+        </p:spPr>
+      </p:pic>
     </p:spTree>
   </p:cSld>
   <p:clrMapOvr>
@@ -11237,61 +11005,30 @@
           </a:p>
         </p:txBody>
       </p:sp>
-      <p:sp>
-        <p:nvSpPr>
-          <p:cNvPr id="19" name="Rectangle 18"/>
-          <p:cNvSpPr/>
-          <p:nvPr/>
-        </p:nvSpPr>
-        <p:spPr>
-          <a:xfrm>
-            <a:off x="548640" y="3931920"/>
-            <a:ext cx="10972800" cy="2194560"/>
+      <p:pic>
+        <p:nvPicPr>
+          <p:cNvPr id="19" name="Picture 18" descr="b01_lead_monica.png"/>
+          <p:cNvPicPr>
+            <a:picLocks noChangeAspect="1"/>
+          </p:cNvPicPr>
+          <p:nvPr/>
+        </p:nvPicPr>
+        <p:blipFill>
+          <a:blip r:embed="rId3"/>
+          <a:stretch>
+            <a:fillRect/>
+          </a:stretch>
+        </p:blipFill>
+        <p:spPr>
+          <a:xfrm>
+            <a:off x="4084320" y="3931920"/>
+            <a:ext cx="3901440" cy="2194560"/>
           </a:xfrm>
           <a:prstGeom prst="rect">
             <a:avLst/>
           </a:prstGeom>
-          <a:solidFill>
-            <a:srgbClr val="F3F6FA"/>
-          </a:solidFill>
-          <a:ln>
-            <a:solidFill>
-              <a:srgbClr val="8A9BB5"/>
-            </a:solidFill>
-            <a:prstDash val="dash"/>
-          </a:ln>
-        </p:spPr>
-        <p:style>
-          <a:lnRef idx="1">
-            <a:schemeClr val="accent1"/>
-          </a:lnRef>
-          <a:fillRef idx="3">
-            <a:schemeClr val="accent1"/>
-          </a:fillRef>
-          <a:effectRef idx="2">
-            <a:schemeClr val="accent1"/>
-          </a:effectRef>
-          <a:fontRef idx="minor">
-            <a:schemeClr val="lt1"/>
-          </a:fontRef>
-        </p:style>
-        <p:txBody>
-          <a:bodyPr rtlCol="0" anchor="ctr" wrap="square"/>
-          <a:lstStyle/>
-          <a:p>
-            <a:pPr algn="ctr"/>
-            <a:r>
-              <a:rPr sz="1400" i="1">
-                <a:solidFill>
-                  <a:srgbClr val="8A9BB5"/>
-                </a:solidFill>
-                <a:latin typeface="Segoe UI"/>
-              </a:rPr>
-              <a:t>[Captura: lead creado desde el sitio y la cotización aceptada en el portal]</a:t>
-            </a:r>
-          </a:p>
-        </p:txBody>
-      </p:sp>
+        </p:spPr>
+      </p:pic>
     </p:spTree>
   </p:cSld>
   <p:clrMapOvr>
@@ -11606,61 +11343,6 @@
       </p:sp>
       <p:sp>
         <p:nvSpPr>
-          <p:cNvPr id="9" name="Rectangle 8"/>
-          <p:cNvSpPr/>
-          <p:nvPr/>
-        </p:nvSpPr>
-        <p:spPr>
-          <a:xfrm>
-            <a:off x="548640" y="1828800"/>
-            <a:ext cx="6766560" cy="4206240"/>
-          </a:xfrm>
-          <a:prstGeom prst="rect">
-            <a:avLst/>
-          </a:prstGeom>
-          <a:solidFill>
-            <a:srgbClr val="F3F6FA"/>
-          </a:solidFill>
-          <a:ln>
-            <a:solidFill>
-              <a:srgbClr val="8A9BB5"/>
-            </a:solidFill>
-            <a:prstDash val="dash"/>
-          </a:ln>
-        </p:spPr>
-        <p:style>
-          <a:lnRef idx="1">
-            <a:schemeClr val="accent1"/>
-          </a:lnRef>
-          <a:fillRef idx="3">
-            <a:schemeClr val="accent1"/>
-          </a:fillRef>
-          <a:effectRef idx="2">
-            <a:schemeClr val="accent1"/>
-          </a:effectRef>
-          <a:fontRef idx="minor">
-            <a:schemeClr val="lt1"/>
-          </a:fontRef>
-        </p:style>
-        <p:txBody>
-          <a:bodyPr rtlCol="0" anchor="ctr" wrap="square"/>
-          <a:lstStyle/>
-          <a:p>
-            <a:pPr algn="ctr"/>
-            <a:r>
-              <a:rPr sz="1400" i="1">
-                <a:solidFill>
-                  <a:srgbClr val="8A9BB5"/>
-                </a:solidFill>
-                <a:latin typeface="Segoe UI"/>
-              </a:rPr>
-              <a:t>[Captura: Mi cuenta: lista de pedidos con su estado y una factura en PDF]</a:t>
-            </a:r>
-          </a:p>
-        </p:txBody>
-      </p:sp>
-      <p:sp>
-        <p:nvSpPr>
           <p:cNvPr id="10" name="TextBox 9"/>
           <p:cNvSpPr txBox="1"/>
           <p:nvPr/>
@@ -11730,6 +11412,30 @@
           </a:p>
         </p:txBody>
       </p:sp>
+      <p:pic>
+        <p:nvPicPr>
+          <p:cNvPr id="11" name="Picture 10" descr="j11.png"/>
+          <p:cNvPicPr>
+            <a:picLocks noChangeAspect="1"/>
+          </p:cNvPicPr>
+          <p:nvPr/>
+        </p:nvPicPr>
+        <p:blipFill>
+          <a:blip r:embed="rId2"/>
+          <a:stretch>
+            <a:fillRect/>
+          </a:stretch>
+        </p:blipFill>
+        <p:spPr>
+          <a:xfrm>
+            <a:off x="739101" y="1828800"/>
+            <a:ext cx="6385638" cy="4206240"/>
+          </a:xfrm>
+          <a:prstGeom prst="rect">
+            <a:avLst/>
+          </a:prstGeom>
+        </p:spPr>
+      </p:pic>
     </p:spTree>
   </p:cSld>
   <p:clrMapOvr>
@@ -12177,13 +11883,12 @@
                     <a:lstStyle/>
                     <a:p>
                       <a:r>
-                        <a:rPr sz="1400" b="0">
+                        <a:rPr sz="1100" b="0">
                           <a:solidFill>
-                            <a:srgbClr val="595959"/>
+                            <a:srgbClr val="4A4A4A"/>
                           </a:solidFill>
-                          <a:latin typeface="Segoe UI"/>
                         </a:rPr>
-                        <a:t>—</a:t>
+                        <a:t>7 pedidos confirmados y facturados</a:t>
                       </a:r>
                     </a:p>
                   </a:txBody>
@@ -12267,13 +11972,12 @@
                     <a:lstStyle/>
                     <a:p>
                       <a:r>
-                        <a:rPr sz="1400" b="0">
+                        <a:rPr sz="1100" b="0">
                           <a:solidFill>
-                            <a:srgbClr val="595959"/>
+                            <a:srgbClr val="4A4A4A"/>
                           </a:solidFill>
-                          <a:latin typeface="Segoe UI"/>
                         </a:rPr>
-                        <a:t>—</a:t>
+                        <a:t>2 cotizaciones aceptadas y pagadas en el portal</a:t>
                       </a:r>
                     </a:p>
                   </a:txBody>
@@ -12357,13 +12061,12 @@
                     <a:lstStyle/>
                     <a:p>
                       <a:r>
-                        <a:rPr sz="1400" b="0">
+                        <a:rPr sz="1100" b="0">
                           <a:solidFill>
-                            <a:srgbClr val="595959"/>
+                            <a:srgbClr val="4A4A4A"/>
                           </a:solidFill>
-                          <a:latin typeface="Segoe UI"/>
                         </a:rPr>
-                        <a:t>—</a:t>
+                        <a:t>Confirmado con el 10 % de descuento aplicado solo</a:t>
                       </a:r>
                     </a:p>
                   </a:txBody>
@@ -12447,13 +12150,12 @@
                     <a:lstStyle/>
                     <a:p>
                       <a:r>
-                        <a:rPr sz="1400" b="0">
+                        <a:rPr sz="1100" b="0">
                           <a:solidFill>
-                            <a:srgbClr val="595959"/>
+                            <a:srgbClr val="4A4A4A"/>
                           </a:solidFill>
-                          <a:latin typeface="Segoe UI"/>
                         </a:rPr>
-                        <a:t>—</a:t>
+                        <a:t>LLA-002 vuelve a la tienda y se compra</a:t>
                       </a:r>
                     </a:p>
                   </a:txBody>
@@ -12537,13 +12239,12 @@
                     <a:lstStyle/>
                     <a:p>
                       <a:r>
-                        <a:rPr sz="1400" b="0">
+                        <a:rPr sz="1100" b="0">
                           <a:solidFill>
-                            <a:srgbClr val="595959"/>
+                            <a:srgbClr val="4A4A4A"/>
                           </a:solidFill>
-                          <a:latin typeface="Segoe UI"/>
                         </a:rPr>
-                        <a:t>—</a:t>
+                        <a:t>S00060 queda como cotización, sin confirmar</a:t>
                       </a:r>
                     </a:p>
                   </a:txBody>

</xml_diff>

<commit_message>
Fase 3: cifras de cierre al corte de la medianoche del 24-10
Entro un pedido mas despues de generar el informe. Se actualizaron las cifras
en las secciones 5.5, 6, 10, 11, 12 y 14, en la tabla de validacion de reportes,
en la presentacion y en el LEEME: 64 pedidos por Q 21,576.00, ticket Q 337.13,
entregas en menos de 24 h 90.4 %, 65 facturas publicadas y 46 cobradas.
</commit_message>
<xml_diff>
--- a/Entrega_Fase3_Grupo14/5_Presentacion/Presentacion_Fase3_Grupo14.pptx
+++ b/Entrega_Fase3_Grupo14/5_Presentacion/Presentacion_Fase3_Grupo14.pptx
@@ -5677,7 +5677,7 @@
                             <a:srgbClr val="4A4A4A"/>
                           </a:solidFill>
                         </a:rPr>
-                        <a:t>Q 339.14</a:t>
+                        <a:t>Q 337.13</a:t>
                       </a:r>
                     </a:p>
                   </a:txBody>
@@ -5853,7 +5853,7 @@
                             <a:srgbClr val="4A4A4A"/>
                           </a:solidFill>
                         </a:rPr>
-                        <a:t>90.2 %</a:t>
+                        <a:t>90.4 %</a:t>
                       </a:r>
                     </a:p>
                   </a:txBody>
@@ -7195,7 +7195,7 @@
                   <a:srgbClr val="4A4A4A"/>
                 </a:solidFill>
               </a:rPr>
-              <a:t>2.  Las cuatro metas operativas de la Fase 1 se cumplen con datos del ERP: ticket de Q 339.14 contra Q 285, recompra del 29.8 % contra 20 %, entregas en menos de 24 horas del 90.2 % contra 90 %, y cero productos en quiebre de 38.</a:t>
+              <a:t>2.  Las cuatro metas operativas de la Fase 1 se cumplen con datos del ERP: ticket de Q 337.13 contra Q 285, recompra del 29.8 % contra 20 %, entregas en menos de 24 horas del 90.4 % contra 90 %, y cero productos en quiebre de 38.</a:t>
             </a:r>
           </a:p>
           <a:p>

</xml_diff>